<commit_message>
release: harden reproducible data intelligence portfolio
</commit_message>
<xml_diff>
--- a/presentation/consumer_finance_complaint_intelligence_presentation.pptx
+++ b/presentation/consumer_finance_complaint_intelligence_presentation.pptx
@@ -2585,7 +2585,7 @@
                   <a:srgbClr val="1F2937"/>
                 </a:solidFill>
               </a:rPr>
-              <a:t>24/24</a:t>
+              <a:t>35/35</a:t>
             </a:r>
             <a:endParaRPr lang="en-US" sz="2300" dirty="0"/>
           </a:p>
@@ -5708,7 +5708,7 @@
                   <a:srgbClr val="1F2937"/>
                 </a:solidFill>
               </a:rPr>
-              <a:t>24 automatisierte Tests · Warning-as-error · Ruff · CI auf Python 3.11 und 3.13</a:t>
+              <a:t>35 automatisierte Tests · Warning-as-error · Ruff · CI auf Python 3.11 und 3.13</a:t>
             </a:r>
             <a:endParaRPr lang="en-US" sz="1250" dirty="0"/>
           </a:p>

</xml_diff>